<commit_message>
Update pitch (md + deck) to delivered results
- pitch.md rewritten: corrected KPI, real baselines, SASRec 0.0735 (98% of paper),
  late-fusion hybrid +9.7%±2.0%, honest mechanism (content helps head not tail)
- Pitch_YMusic.pptx slides 2-6: fix fabricated KPI (0.38/0.44), remove the
  disproven cold-start claim, free-GPU framing, 50M-slice + 128-d/82% data notes

Co-Authored-By: Claude Opus 4.8 (1M context) <noreply@anthropic.com>
</commit_message>
<xml_diff>
--- a/Pitch_YMusic.pptx
+++ b/Pitch_YMusic.pptx
@@ -6688,7 +6688,7 @@
                 <a:uFillTx/>
                 <a:latin typeface="Calibri"/>
               </a:rPr>
-              <a:t>—  A +15 % relative lift in next-track accuracy is the difference between catching up and leading.</a:t>
+              <a:t>—  A few % lift in next-track ranking separates catching up from leading.</a:t>
             </a:r>
             <a:endParaRPr lang="ru-RU" sz="1600" b="0" u="none" strike="noStrike">
               <a:solidFill>
@@ -7146,7 +7146,7 @@
                 <a:uFillTx/>
                 <a:latin typeface="Calibri"/>
               </a:rPr>
-              <a:t>—  1 M users   ·   9.39 M tracks   ·   4.79 B events</a:t>
+              <a:t>—  1 M users · 9.39 M tracks · 4.79 B events (we train on the 50M slice)</a:t>
             </a:r>
             <a:endParaRPr lang="ru-RU" sz="1500" b="0" u="none" strike="noStrike">
               <a:solidFill>
@@ -7260,7 +7260,7 @@
                 <a:uFillTx/>
                 <a:latin typeface="Calibri"/>
               </a:rPr>
-              <a:t>—  Three signal layers: explicit feedback (likes / dislikes), implicit (plays / skips / replays), and precomputed audio embeddings.</a:t>
+              <a:t>—  Three signal layers: explicit (likes / dislikes), implicit (plays / skips / replays), and 128-d audio embeddings (82% of tracks).</a:t>
             </a:r>
             <a:endParaRPr lang="ru-RU" sz="1500" b="0" u="none" strike="noStrike">
               <a:solidFill>
@@ -7970,7 +7970,7 @@
                 <a:uFillTx/>
                 <a:latin typeface="Calibri"/>
               </a:rPr>
-              <a:t>—  User-tower / item-tower trained on Yambda's precomputed audio embeddings.</a:t>
+              <a:t>—  Content tower on Yandex audio embeddings (128-d) — audio taste similarity.</a:t>
             </a:r>
             <a:endParaRPr lang="ru-RU" sz="1400" b="0" u="none" strike="noStrike">
               <a:solidFill>
@@ -8028,7 +8028,7 @@
                 <a:uFillTx/>
                 <a:latin typeface="Calibri"/>
               </a:rPr>
-              <a:t>—  Directly fixes the cold-start problem that breaks pure collaborative filtering.</a:t>
+              <a:t>—  Adds an audio-taste signal complementary to the sequence model.</a:t>
             </a:r>
             <a:endParaRPr lang="ru-RU" sz="1400" b="0" u="none" strike="noStrike">
               <a:solidFill>
@@ -8164,7 +8164,7 @@
                 <a:uFillTx/>
                 <a:latin typeface="Calibri"/>
               </a:rPr>
-              <a:t>—  Outputs combined with learned weights — model picks behavioural-vs-content balance automatically.</a:t>
+              <a:t>—  Outputs fused with a validation-tuned weight (β) — late, not joint, fusion.</a:t>
             </a:r>
             <a:endParaRPr lang="ru-RU" sz="1300" b="0" u="none" strike="noStrike">
               <a:solidFill>
@@ -8708,7 +8708,7 @@
                 <a:uFillTx/>
                 <a:latin typeface="Calibri"/>
               </a:rPr>
-              <a:t>Targets</a:t>
+              <a:t>Results</a:t>
             </a:r>
             <a:endParaRPr lang="ru-RU" sz="1600" b="0" u="none" strike="noStrike">
               <a:solidFill>
@@ -8765,7 +8765,7 @@
                 <a:uFillTx/>
                 <a:latin typeface="Calibri"/>
               </a:rPr>
-              <a:t>—  Yandex BPR baseline:  NDCG@10 ≈ 0.38</a:t>
+              <a:t>—  Best baselines:  ItemKNN 0.071, SASRec 0.0735</a:t>
             </a:r>
             <a:endParaRPr lang="ru-RU" sz="1500" b="0" u="none" strike="noStrike">
               <a:solidFill>
@@ -8794,7 +8794,7 @@
                 <a:uFillTx/>
                 <a:latin typeface="Calibri"/>
               </a:rPr>
-              <a:t>—  Our goal:  NDCG@10 ≥ 0.44   (+15 % relative)</a:t>
+              <a:t>—  Our hybrid:  +9.7% ± 2.0% over SASRec (5 splits)</a:t>
             </a:r>
             <a:endParaRPr lang="ru-RU" sz="1500" b="0" u="none" strike="noStrike">
               <a:solidFill>
@@ -8908,7 +8908,7 @@
                 <a:uFillTx/>
                 <a:latin typeface="Calibri"/>
               </a:rPr>
-              <a:t>—  +18 – 22 % listening time per active user.</a:t>
+              <a:t>—  +9.7% better next-track ranking (NDCG@10) per user.</a:t>
             </a:r>
             <a:endParaRPr lang="ru-RU" sz="1400" b="0" u="none" strike="noStrike">
               <a:solidFill>
@@ -8937,7 +8937,7 @@
                 <a:uFillTx/>
                 <a:latin typeface="Calibri"/>
               </a:rPr>
-              <a:t>—  − 10 % monthly churn.</a:t>
+              <a:t>—  Stronger discovery → lever on listening time and churn.</a:t>
             </a:r>
             <a:endParaRPr lang="ru-RU" sz="1400" b="0" u="none" strike="noStrike">
               <a:solidFill>
@@ -8966,7 +8966,7 @@
                 <a:uFillTx/>
                 <a:latin typeface="Calibri"/>
               </a:rPr>
-              <a:t>—  +3 – 5 M ₽ / month subscription revenue at Yandex Music scale.</a:t>
+              <a:t>—  Delivered on free data + one free GPU (near-zero cost).</a:t>
             </a:r>
             <a:endParaRPr lang="ru-RU" sz="1400" b="0" u="none" strike="noStrike">
               <a:solidFill>
@@ -9349,7 +9349,7 @@
                 <a:uFillTx/>
                 <a:latin typeface="Calibri"/>
               </a:rPr>
-              <a:t>Real Yandex listening data (Yambda, 4.79 B events) → hybrid neural recommender — SASRec sequence model + two-tower content network on audio embeddings → predict the next track for a streaming user. Success bar: NDCG@10 ≥ 0.44 (+15 % over the published Yandex baseline). Business impact: longer sessions, lower churn, measurable revenue lift.</a:t>
+              <a:t>Real Yandex listening data (Yambda-50M) → hybrid neural recommender: SASRec sequence model + audio-content tower, fused with a validation-tuned weight → predict the next track. Delivered: SASRec beats every baseline and reproduces the paper to 98%; late fusion adds a robust +9.7% ± 2.0% NDCG@10 over SASRec across 5 held-out user splits.</a:t>
             </a:r>
             <a:endParaRPr lang="ru-RU" sz="1700" b="0" u="none" strike="noStrike">
               <a:solidFill>
@@ -9428,7 +9428,7 @@
                 <a:uFillTx/>
                 <a:latin typeface="Calibri"/>
               </a:rPr>
-              <a:t>What we need to execute</a:t>
+              <a:t>What it took</a:t>
             </a:r>
             <a:endParaRPr lang="ru-RU" sz="1600" b="0" u="none" strike="noStrike">
               <a:solidFill>
@@ -9514,7 +9514,7 @@
                 <a:uFillTx/>
                 <a:latin typeface="Calibri"/>
               </a:rPr>
-              <a:t>—  GPU instance with 80 – 160 GB memory (Colab Pro+ or Yandex Cloud) for 1 – 2 weeks.</a:t>
+              <a:t>—  One free Kaggle T4 (16 GB) GPU — no paid infrastructure.</a:t>
             </a:r>
             <a:endParaRPr lang="ru-RU" sz="1500" b="0" u="none" strike="noStrike">
               <a:solidFill>
@@ -9543,7 +9543,7 @@
                 <a:uFillTx/>
                 <a:latin typeface="Calibri"/>
               </a:rPr>
-              <a:t>—  Two project weeks end-to-end:  pipeline + baselines, then hybrid model + evaluation.</a:t>
+              <a:t>—  Reproducible pipeline: baselines → SASRec → fusion → robustness.</a:t>
             </a:r>
             <a:endParaRPr lang="ru-RU" sz="1500" b="0" u="none" strike="noStrike">
               <a:solidFill>

</xml_diff>

<commit_message>
Add Pitch_YMusic.pdf (deck as PDF) + repo link on slides; build script
LibreOffice (broken Python bootstrap) and PowerPoint were unavailable locally,
so the deck is rendered to PDF via headless Chromium (scripts/build_pitch_pdf.py),
content-faithful to Pitch_YMusic.pptx. Repo link added to title + summary slides
(reproducibility). PDF is the smartLMS submission artifact.

Co-Authored-By: Claude Opus 4.8 (1M context) <noreply@anthropic.com>
</commit_message>
<xml_diff>
--- a/Pitch_YMusic.pptx
+++ b/Pitch_YMusic.pptx
@@ -6172,7 +6172,7 @@
                 <a:uFillTx/>
                 <a:latin typeface="Calibri"/>
               </a:rPr>
-              <a:t>HSE Master's · NNDL · Module 2</a:t>
+              <a:t>HSE Master's · NNDL · Module 2     ·     github.com/ak1232320/nndl_capstone_2026</a:t>
             </a:r>
             <a:endParaRPr lang="ru-RU" sz="1200" b="0" u="none" strike="noStrike">
               <a:solidFill>
@@ -9543,7 +9543,7 @@
                 <a:uFillTx/>
                 <a:latin typeface="Calibri"/>
               </a:rPr>
-              <a:t>—  Reproducible pipeline: baselines → SASRec → fusion → robustness.</a:t>
+              <a:t>—  Reproducible: github.com/ak1232320/nndl_capstone_2026  (pipeline 00-07).</a:t>
             </a:r>
             <a:endParaRPr lang="ru-RU" sz="1500" b="0" u="none" strike="noStrike">
               <a:solidFill>

</xml_diff>

<commit_message>
Honest +6-10% lift framing + commit executed notebooks
- Lift varies run-to-run (GPU non-determinism): two full runs gave +6.0%±2.8%
  and +9.7%±2.0%. Reframe all materials (README, REPORT md+pdf, pitch md + deck
  pptx+pdf, figures) to a robust +6-10%, positive on every split and run.
- Canonical numbers now from the committed end-to-end run.
- Add notebooks/executed/{RUN_ALL,06_robustness}.ipynb (with outputs) so results
  are visible without running.

Co-Authored-By: Claude Opus 4.8 (1M context) <noreply@anthropic.com>
</commit_message>
<xml_diff>
--- a/Pitch_YMusic.pptx
+++ b/Pitch_YMusic.pptx
@@ -8794,7 +8794,7 @@
                 <a:uFillTx/>
                 <a:latin typeface="Calibri"/>
               </a:rPr>
-              <a:t>—  Our hybrid:  +9.7% ± 2.0% over SASRec (5 splits)</a:t>
+              <a:t>—  Our hybrid:  +6-10% over SASRec (robust, every split positive)</a:t>
             </a:r>
             <a:endParaRPr lang="ru-RU" sz="1500" b="0" u="none" strike="noStrike">
               <a:solidFill>
@@ -8908,7 +8908,7 @@
                 <a:uFillTx/>
                 <a:latin typeface="Calibri"/>
               </a:rPr>
-              <a:t>—  +9.7% better next-track ranking (NDCG@10) per user.</a:t>
+              <a:t>—  +6-10% better next-track ranking (NDCG@10) per user.</a:t>
             </a:r>
             <a:endParaRPr lang="ru-RU" sz="1400" b="0" u="none" strike="noStrike">
               <a:solidFill>
@@ -9349,7 +9349,7 @@
                 <a:uFillTx/>
                 <a:latin typeface="Calibri"/>
               </a:rPr>
-              <a:t>Real Yandex listening data (Yambda-50M) → hybrid neural recommender: SASRec sequence model + audio-content tower, fused with a validation-tuned weight → predict the next track. Delivered: SASRec beats every baseline and reproduces the paper to 98%; late fusion adds a robust +9.7% ± 2.0% NDCG@10 over SASRec across 5 held-out user splits.</a:t>
+              <a:t>Real Yandex listening data (Yambda-50M) → hybrid neural recommender: SASRec sequence model + audio-content tower, fused with a validation-tuned weight → predict the next track. Delivered: SASRec beats every baseline and reproduces the paper to 98%; late fusion adds a robust +6-10% NDCG@10 over SASRec, positive on every split and run.</a:t>
             </a:r>
             <a:endParaRPr lang="ru-RU" sz="1700" b="0" u="none" strike="noStrike">
               <a:solidFill>

</xml_diff>